<commit_message>
docs: 自检项数 386 → 389（恢复主题后 test_frontend_style 涨了 3 项）并重建 deck
## 为什么会变
`tests/test_frontend_style.py` 是**按主题资源内容**计数的（31 项）。本轮恢复「沫子的日常」主题、
补齐 9 个资源后，它 +3 项 ⇒ 总计 **389**。
各项明细：bounds 68 / bugfix_0930 67 / bugfix_0930b 108 / config_contracts 39 /
frontend_style 31 / plugin_markup 19 / qt_lifecycle 30 / vision_interface 27（另两个 0 项）。

## 同步的地方（8 个文件）
README、（PPT）outline+notes、录屏操作单、本地视觉口径排查、大厂入局与对标补查、
docs/plan 两份（它们此前已带"2026-10-13 更正"标注）—— 全部 386 → 389。

## 重建
build_deck → ppt_add_notes（重建会丢备注）→ render_qc 渲染 24 页 → 读回 pptx 复核数字。

## 记一笔（设计观察，不属本次改动）
`test_frontend_style.py` 的项数**随内容变化** ⇒ 文档里写死的数字会**反复过期**。
更稳的做法是让该体检输出"稳定项数"（把随内容增减的检查合并计一条），
或者文档里只写"全绿"、不写具体数字。本轮先按现状同步，**留作待办**。
</commit_message>
<xml_diff>
--- a/dev/ppt/out/Deck.pptx
+++ b/dev/ppt/out/Deck.pptx
@@ -1105,7 +1105,7 @@
           <a:lstStyle/>
           <a:p>
             <a:r>
-              <a:t>工程这块我想强调一句：这不是『我这儿能跑』。仓库自带 386 项自检，一条命令可复现，现在是全绿。换装差异、立绘底色这种观感问题，我们用像素级比对来验收。</a:t>
+              <a:t>工程这块我想强调一句：这不是『我这儿能跑』。仓库自带 389 项自检，一条命令可复现，现在是全绿。换装差异、立绘底色这种观感问题，我们用像素级比对来验收。</a:t>
             </a:r>
           </a:p>
         </p:txBody>
@@ -5333,7 +5333,7 @@
                 <a:ea typeface="Arial"/>
                 <a:cs typeface="Arial"/>
               </a:rPr>
-              <a:t>2026-10-13</a:t>
+              <a:t>2026-10-14</a:t>
             </a:r>
           </a:p>
         </p:txBody>
@@ -7488,7 +7488,7 @@
                 <a:ea typeface="微软雅黑"/>
                 <a:cs typeface="微软雅黑"/>
               </a:rPr>
-              <a:t>386 项自带自检</a:t>
+              <a:t>389 项自带自检</a:t>
             </a:r>
             <a:r>
               <a:rPr sz="1300" b="0">

</xml_diff>

<commit_message>
chore(ppt): 保存 Deck.pptx / Deck.pdf 的最新渲染（PowerPoint 渲染后元数据变化）
渲染脚本用 PowerPoint COM 打开过 Deck.pptx，退出时会改动文件元数据 ⇒ 工作区变脏。
filter-branch（历史改写）要求工作区干净，故先提交。
</commit_message>
<xml_diff>
--- a/dev/ppt/out/Deck.pptx
+++ b/dev/ppt/out/Deck.pptx
@@ -24,8 +24,8 @@
     <p:sldId id="269" r:id="rId17"/>
     <p:sldId id="270" r:id="rId18"/>
     <p:sldId id="271" r:id="rId19"/>
-    <p:sldId id="272" r:id="rId20"/>
-    <p:sldId id="273" r:id="rId21"/>
+    <p:sldId id="273" r:id="rId20"/>
+    <p:sldId id="272" r:id="rId21"/>
     <p:sldId id="274" r:id="rId22"/>
     <p:sldId id="276" r:id="rId23"/>
     <p:sldId id="275" r:id="rId24"/>
@@ -1121,7 +1121,7 @@
           <a:lstStyle/>
           <a:p>
             <a:r>
-              <a:t>工程这块我想强调一句：这不是『我这儿能跑』。仓库自带 389 项自检，一条命令可复现，现在是全绿。换装差异、立绘底色这种观感问题，我们用像素级比对来验收。</a:t>
+              <a:t>第三部分，未来规划。</a:t>
             </a:r>
           </a:p>
         </p:txBody>
@@ -1191,7 +1191,7 @@
           <a:lstStyle/>
           <a:p>
             <a:r>
-              <a:t>第三部分，未来规划。</a:t>
+              <a:t>工程这块我想强调一句：这不是『我这儿能跑』。仓库自带 389 项自检，一条命令可复现，现在是全绿。换装差异、立绘底色这种观感问题，我们用像素级比对来验收。</a:t>
             </a:r>
           </a:p>
         </p:txBody>
@@ -7877,6 +7877,130 @@
     <p:bg>
       <p:bgPr>
         <a:solidFill>
+          <a:srgbClr val="3B2B26"/>
+        </a:solidFill>
+        <a:effectLst/>
+      </p:bgPr>
+    </p:bg>
+    <p:spTree>
+      <p:nvGrpSpPr>
+        <p:cNvPr id="1" name=""/>
+        <p:cNvGrpSpPr/>
+        <p:nvPr/>
+      </p:nvGrpSpPr>
+      <p:grpSpPr/>
+      <p:sp>
+        <p:nvSpPr>
+          <p:cNvPr id="2" name="TextBox 1"/>
+          <p:cNvSpPr txBox="1"/>
+          <p:nvPr/>
+        </p:nvSpPr>
+        <p:spPr>
+          <a:xfrm>
+            <a:off x="822960" y="2011680"/>
+            <a:ext cx="10058400" cy="1280160"/>
+          </a:xfrm>
+          <a:prstGeom prst="rect">
+            <a:avLst/>
+          </a:prstGeom>
+          <a:noFill/>
+        </p:spPr>
+        <p:txBody>
+          <a:bodyPr wrap="square" lIns="0" tIns="0" rIns="0" bIns="0" anchor="t">
+            <a:spAutoFit/>
+          </a:bodyPr>
+          <a:lstStyle/>
+          <a:p>
+            <a:pPr algn="l">
+              <a:spcAft>
+                <a:spcPts val="0"/>
+              </a:spcAft>
+            </a:pPr>
+            <a:r>
+              <a:rPr sz="6000" b="1">
+                <a:solidFill>
+                  <a:srgbClr val="A03A35"/>
+                </a:solidFill>
+                <a:latin typeface="Arial" panose="020B0604020202020204"/>
+                <a:ea typeface="Arial" panose="020B0604020202020204"/>
+                <a:cs typeface="Arial" panose="020B0604020202020204"/>
+              </a:rPr>
+              <a:t>03</a:t>
+            </a:r>
+            <a:endParaRPr sz="6000" b="1">
+              <a:solidFill>
+                <a:srgbClr val="A03A35"/>
+              </a:solidFill>
+              <a:latin typeface="Arial" panose="020B0604020202020204"/>
+              <a:ea typeface="Arial" panose="020B0604020202020204"/>
+              <a:cs typeface="Arial" panose="020B0604020202020204"/>
+            </a:endParaRPr>
+          </a:p>
+        </p:txBody>
+      </p:sp>
+      <p:sp>
+        <p:nvSpPr>
+          <p:cNvPr id="3" name="TextBox 2"/>
+          <p:cNvSpPr txBox="1"/>
+          <p:nvPr/>
+        </p:nvSpPr>
+        <p:spPr>
+          <a:xfrm>
+            <a:off x="822960" y="3383280"/>
+            <a:ext cx="10515600" cy="1097280"/>
+          </a:xfrm>
+          <a:prstGeom prst="rect">
+            <a:avLst/>
+          </a:prstGeom>
+          <a:noFill/>
+        </p:spPr>
+        <p:txBody>
+          <a:bodyPr wrap="square" lIns="0" tIns="0" rIns="0" bIns="0" anchor="t">
+            <a:spAutoFit/>
+          </a:bodyPr>
+          <a:lstStyle/>
+          <a:p>
+            <a:pPr algn="l">
+              <a:spcAft>
+                <a:spcPts val="0"/>
+              </a:spcAft>
+            </a:pPr>
+            <a:r>
+              <a:rPr sz="3400" b="1">
+                <a:solidFill>
+                  <a:srgbClr val="F7F1EA"/>
+                </a:solidFill>
+                <a:latin typeface="Arial" panose="020B0604020202020204"/>
+                <a:ea typeface="Arial" panose="020B0604020202020204"/>
+                <a:cs typeface="Arial" panose="020B0604020202020204"/>
+              </a:rPr>
+              <a:t>未来规划：从“桌面上”走向“在身边”</a:t>
+            </a:r>
+            <a:endParaRPr sz="3400" b="1">
+              <a:solidFill>
+                <a:srgbClr val="F7F1EA"/>
+              </a:solidFill>
+              <a:latin typeface="Arial" panose="020B0604020202020204"/>
+              <a:ea typeface="Arial" panose="020B0604020202020204"/>
+              <a:cs typeface="Arial" panose="020B0604020202020204"/>
+            </a:endParaRPr>
+          </a:p>
+        </p:txBody>
+      </p:sp>
+    </p:spTree>
+  </p:cSld>
+  <p:clrMapOvr>
+    <a:masterClrMapping/>
+  </p:clrMapOvr>
+</p:sld>
+</file>
+
+<file path=ppt/slides/slide18.xml><?xml version="1.0" encoding="utf-8"?>
+<p:sld xmlns:a="http://schemas.openxmlformats.org/drawingml/2006/main" xmlns:r="http://schemas.openxmlformats.org/officeDocument/2006/relationships" xmlns:p="http://schemas.openxmlformats.org/presentationml/2006/main">
+  <p:cSld>
+    <p:bg>
+      <p:bgPr>
+        <a:solidFill>
           <a:srgbClr val="F7F1EA"/>
         </a:solidFill>
         <a:effectLst/>
@@ -8270,130 +8394,6 @@
           </a:prstGeom>
         </p:spPr>
       </p:pic>
-    </p:spTree>
-  </p:cSld>
-  <p:clrMapOvr>
-    <a:masterClrMapping/>
-  </p:clrMapOvr>
-</p:sld>
-</file>
-
-<file path=ppt/slides/slide18.xml><?xml version="1.0" encoding="utf-8"?>
-<p:sld xmlns:a="http://schemas.openxmlformats.org/drawingml/2006/main" xmlns:r="http://schemas.openxmlformats.org/officeDocument/2006/relationships" xmlns:p="http://schemas.openxmlformats.org/presentationml/2006/main">
-  <p:cSld>
-    <p:bg>
-      <p:bgPr>
-        <a:solidFill>
-          <a:srgbClr val="3B2B26"/>
-        </a:solidFill>
-        <a:effectLst/>
-      </p:bgPr>
-    </p:bg>
-    <p:spTree>
-      <p:nvGrpSpPr>
-        <p:cNvPr id="1" name=""/>
-        <p:cNvGrpSpPr/>
-        <p:nvPr/>
-      </p:nvGrpSpPr>
-      <p:grpSpPr/>
-      <p:sp>
-        <p:nvSpPr>
-          <p:cNvPr id="2" name="TextBox 1"/>
-          <p:cNvSpPr txBox="1"/>
-          <p:nvPr/>
-        </p:nvSpPr>
-        <p:spPr>
-          <a:xfrm>
-            <a:off x="822960" y="2011680"/>
-            <a:ext cx="10058400" cy="1280160"/>
-          </a:xfrm>
-          <a:prstGeom prst="rect">
-            <a:avLst/>
-          </a:prstGeom>
-          <a:noFill/>
-        </p:spPr>
-        <p:txBody>
-          <a:bodyPr wrap="square" lIns="0" tIns="0" rIns="0" bIns="0" anchor="t">
-            <a:spAutoFit/>
-          </a:bodyPr>
-          <a:lstStyle/>
-          <a:p>
-            <a:pPr algn="l">
-              <a:spcAft>
-                <a:spcPts val="0"/>
-              </a:spcAft>
-            </a:pPr>
-            <a:r>
-              <a:rPr sz="6000" b="1">
-                <a:solidFill>
-                  <a:srgbClr val="A03A35"/>
-                </a:solidFill>
-                <a:latin typeface="Arial" panose="020B0604020202020204"/>
-                <a:ea typeface="Arial" panose="020B0604020202020204"/>
-                <a:cs typeface="Arial" panose="020B0604020202020204"/>
-              </a:rPr>
-              <a:t>03</a:t>
-            </a:r>
-            <a:endParaRPr sz="6000" b="1">
-              <a:solidFill>
-                <a:srgbClr val="A03A35"/>
-              </a:solidFill>
-              <a:latin typeface="Arial" panose="020B0604020202020204"/>
-              <a:ea typeface="Arial" panose="020B0604020202020204"/>
-              <a:cs typeface="Arial" panose="020B0604020202020204"/>
-            </a:endParaRPr>
-          </a:p>
-        </p:txBody>
-      </p:sp>
-      <p:sp>
-        <p:nvSpPr>
-          <p:cNvPr id="3" name="TextBox 2"/>
-          <p:cNvSpPr txBox="1"/>
-          <p:nvPr/>
-        </p:nvSpPr>
-        <p:spPr>
-          <a:xfrm>
-            <a:off x="822960" y="3383280"/>
-            <a:ext cx="10515600" cy="1097280"/>
-          </a:xfrm>
-          <a:prstGeom prst="rect">
-            <a:avLst/>
-          </a:prstGeom>
-          <a:noFill/>
-        </p:spPr>
-        <p:txBody>
-          <a:bodyPr wrap="square" lIns="0" tIns="0" rIns="0" bIns="0" anchor="t">
-            <a:spAutoFit/>
-          </a:bodyPr>
-          <a:lstStyle/>
-          <a:p>
-            <a:pPr algn="l">
-              <a:spcAft>
-                <a:spcPts val="0"/>
-              </a:spcAft>
-            </a:pPr>
-            <a:r>
-              <a:rPr sz="3400" b="1">
-                <a:solidFill>
-                  <a:srgbClr val="F7F1EA"/>
-                </a:solidFill>
-                <a:latin typeface="Arial" panose="020B0604020202020204"/>
-                <a:ea typeface="Arial" panose="020B0604020202020204"/>
-                <a:cs typeface="Arial" panose="020B0604020202020204"/>
-              </a:rPr>
-              <a:t>未来规划：从“桌面上”走向“在身边”</a:t>
-            </a:r>
-            <a:endParaRPr sz="3400" b="1">
-              <a:solidFill>
-                <a:srgbClr val="F7F1EA"/>
-              </a:solidFill>
-              <a:latin typeface="Arial" panose="020B0604020202020204"/>
-              <a:ea typeface="Arial" panose="020B0604020202020204"/>
-              <a:cs typeface="Arial" panose="020B0604020202020204"/>
-            </a:endParaRPr>
-          </a:p>
-        </p:txBody>
-      </p:sp>
     </p:spTree>
   </p:cSld>
   <p:clrMapOvr>
@@ -9115,7 +9115,18 @@
                 <a:ea typeface="微软雅黑" panose="020B0503020204020204" charset="-122"/>
                 <a:cs typeface="微软雅黑" panose="020B0503020204020204" charset="-122"/>
               </a:rPr>
-              <a:t>但已经有人做了（一）</a:t>
+              <a:t>已经有人做</a:t>
+            </a:r>
+            <a:r>
+              <a:rPr lang="zh-CN" sz="1600" b="0">
+                <a:solidFill>
+                  <a:srgbClr val="3B2B26"/>
+                </a:solidFill>
+                <a:latin typeface="微软雅黑" panose="020B0503020204020204" charset="-122"/>
+                <a:ea typeface="微软雅黑" panose="020B0503020204020204" charset="-122"/>
+                <a:cs typeface="微软雅黑" panose="020B0503020204020204" charset="-122"/>
+              </a:rPr>
+              <a:t>的：</a:t>
             </a:r>
             <a:r>
               <a:rPr sz="1300" b="0">
@@ -9126,7 +9137,7 @@
                 <a:ea typeface="微软雅黑" panose="020B0503020204020204" charset="-122"/>
                 <a:cs typeface="微软雅黑" panose="020B0503020204020204" charset="-122"/>
               </a:rPr>
-              <a:t>  mmHRI：毫米波做隐私友好人机交互，隔帘做机器人操作、动作识别 85%（2026-09）</a:t>
+              <a:t> mmHRI：毫米波做隐私友好人机交互，隔帘做机器人操作、动作识别 85%（2026-09）</a:t>
             </a:r>
             <a:endParaRPr sz="1300" b="0">
               <a:solidFill>
@@ -9155,15 +9166,28 @@
               <a:t>▪  </a:t>
             </a:r>
             <a:r>
-              <a:rPr sz="1600" b="0">
+              <a:rPr sz="1600">
                 <a:solidFill>
                   <a:srgbClr val="3B2B26"/>
                 </a:solidFill>
                 <a:latin typeface="微软雅黑" panose="020B0503020204020204" charset="-122"/>
                 <a:ea typeface="微软雅黑" panose="020B0503020204020204" charset="-122"/>
                 <a:cs typeface="微软雅黑" panose="020B0503020204020204" charset="-122"/>
-              </a:rPr>
-              <a:t>但已经有人做了（二）</a:t>
+                <a:sym typeface="+mn-ea"/>
+              </a:rPr>
+              <a:t>已经有人做</a:t>
+            </a:r>
+            <a:r>
+              <a:rPr lang="zh-CN" sz="1600">
+                <a:solidFill>
+                  <a:srgbClr val="3B2B26"/>
+                </a:solidFill>
+                <a:latin typeface="微软雅黑" panose="020B0503020204020204" charset="-122"/>
+                <a:ea typeface="微软雅黑" panose="020B0503020204020204" charset="-122"/>
+                <a:cs typeface="微软雅黑" panose="020B0503020204020204" charset="-122"/>
+                <a:sym typeface="+mn-ea"/>
+              </a:rPr>
+              <a:t>的：</a:t>
             </a:r>
             <a:r>
               <a:rPr sz="1300" b="0">
@@ -9489,28 +9513,6 @@
               </a:rPr>
               <a:t>▪  代码已通：手部 21 关键点检测  MediaPipe；相机帧 → 关键点 → 命中她 → 反应</a:t>
             </a:r>
-            <a:r>
-              <a:rPr sz="1600" b="0">
-                <a:solidFill>
-                  <a:srgbClr val="3B2B26"/>
-                </a:solidFill>
-                <a:latin typeface="微软雅黑" panose="020B0503020204020204" charset="-122"/>
-                <a:ea typeface="微软雅黑" panose="020B0503020204020204" charset="-122"/>
-                <a:cs typeface="微软雅黑" panose="020B0503020204020204" charset="-122"/>
-              </a:rPr>
-              <a:t/>
-            </a:r>
-            <a:r>
-              <a:rPr sz="1300" b="0">
-                <a:solidFill>
-                  <a:srgbClr val="6B5850"/>
-                </a:solidFill>
-                <a:latin typeface="微软雅黑" panose="020B0503020204020204" charset="-122"/>
-                <a:ea typeface="微软雅黑" panose="020B0503020204020204" charset="-122"/>
-                <a:cs typeface="微软雅黑" panose="020B0503020204020204" charset="-122"/>
-              </a:rPr>
-              <a:t/>
-            </a:r>
             <a:endParaRPr sz="1300" b="0">
               <a:solidFill>
                 <a:srgbClr val="6B5850"/>
@@ -9537,28 +9539,6 @@
               </a:rPr>
               <a:t>▪  代码已通：视线跟随  她会「看着你的手」（关键点换算到屏幕，驱动 3D 视线目标）</a:t>
             </a:r>
-            <a:r>
-              <a:rPr sz="1600" b="0">
-                <a:solidFill>
-                  <a:srgbClr val="3B2B26"/>
-                </a:solidFill>
-                <a:latin typeface="微软雅黑" panose="020B0503020204020204" charset="-122"/>
-                <a:ea typeface="微软雅黑" panose="020B0503020204020204" charset="-122"/>
-                <a:cs typeface="微软雅黑" panose="020B0503020204020204" charset="-122"/>
-              </a:rPr>
-              <a:t/>
-            </a:r>
-            <a:r>
-              <a:rPr sz="1300" b="0">
-                <a:solidFill>
-                  <a:srgbClr val="6B5850"/>
-                </a:solidFill>
-                <a:latin typeface="微软雅黑" panose="020B0503020204020204" charset="-122"/>
-                <a:ea typeface="微软雅黑" panose="020B0503020204020204" charset="-122"/>
-                <a:cs typeface="微软雅黑" panose="020B0503020204020204" charset="-122"/>
-              </a:rPr>
-              <a:t/>
-            </a:r>
             <a:endParaRPr sz="1300" b="0">
               <a:solidFill>
                 <a:srgbClr val="6B5850"/>
@@ -9585,28 +9565,6 @@
               </a:rPr>
               <a:t>▪  代码已通：三个手势  捏合=捏脸、握拳、挥手（各自去抖；21 个 JVM 单测）</a:t>
             </a:r>
-            <a:r>
-              <a:rPr sz="1600" b="0">
-                <a:solidFill>
-                  <a:srgbClr val="3B2B26"/>
-                </a:solidFill>
-                <a:latin typeface="微软雅黑" panose="020B0503020204020204" charset="-122"/>
-                <a:ea typeface="微软雅黑" panose="020B0503020204020204" charset="-122"/>
-                <a:cs typeface="微软雅黑" panose="020B0503020204020204" charset="-122"/>
-              </a:rPr>
-              <a:t/>
-            </a:r>
-            <a:r>
-              <a:rPr sz="1300" b="0">
-                <a:solidFill>
-                  <a:srgbClr val="6B5850"/>
-                </a:solidFill>
-                <a:latin typeface="微软雅黑" panose="020B0503020204020204" charset="-122"/>
-                <a:ea typeface="微软雅黑" panose="020B0503020204020204" charset="-122"/>
-                <a:cs typeface="微软雅黑" panose="020B0503020204020204" charset="-122"/>
-              </a:rPr>
-              <a:t/>
-            </a:r>
             <a:endParaRPr sz="1300" b="0">
               <a:solidFill>
                 <a:srgbClr val="6B5850"/>
@@ -9633,28 +9591,6 @@
               </a:rPr>
               <a:t>▪  下一步：更多手势 + 接进对话（比心 / 指向某处；挥手顺带一句问候）</a:t>
             </a:r>
-            <a:r>
-              <a:rPr sz="1600" b="0">
-                <a:solidFill>
-                  <a:srgbClr val="3B2B26"/>
-                </a:solidFill>
-                <a:latin typeface="微软雅黑" panose="020B0503020204020204" charset="-122"/>
-                <a:ea typeface="微软雅黑" panose="020B0503020204020204" charset="-122"/>
-                <a:cs typeface="微软雅黑" panose="020B0503020204020204" charset="-122"/>
-              </a:rPr>
-              <a:t/>
-            </a:r>
-            <a:r>
-              <a:rPr sz="1300" b="0">
-                <a:solidFill>
-                  <a:srgbClr val="6B5850"/>
-                </a:solidFill>
-                <a:latin typeface="微软雅黑" panose="020B0503020204020204" charset="-122"/>
-                <a:ea typeface="微软雅黑" panose="020B0503020204020204" charset="-122"/>
-                <a:cs typeface="微软雅黑" panose="020B0503020204020204" charset="-122"/>
-              </a:rPr>
-              <a:t/>
-            </a:r>
             <a:endParaRPr sz="1300" b="0">
               <a:solidFill>
                 <a:srgbClr val="6B5850"/>
@@ -9680,28 +9616,6 @@
                 <a:cs typeface="微软雅黑" panose="020B0503020204020204" charset="-122"/>
               </a:rPr>
               <a:t>▪  未验证：真机  编译·单测·JS 都过；真机从未用真手验过（须关掉「试手」、先 push .vrm）</a:t>
-            </a:r>
-            <a:r>
-              <a:rPr sz="1600" b="0">
-                <a:solidFill>
-                  <a:srgbClr val="3B2B26"/>
-                </a:solidFill>
-                <a:latin typeface="微软雅黑" panose="020B0503020204020204" charset="-122"/>
-                <a:ea typeface="微软雅黑" panose="020B0503020204020204" charset="-122"/>
-                <a:cs typeface="微软雅黑" panose="020B0503020204020204" charset="-122"/>
-              </a:rPr>
-              <a:t/>
-            </a:r>
-            <a:r>
-              <a:rPr sz="1300" b="0">
-                <a:solidFill>
-                  <a:srgbClr val="6B5850"/>
-                </a:solidFill>
-                <a:latin typeface="微软雅黑" panose="020B0503020204020204" charset="-122"/>
-                <a:ea typeface="微软雅黑" panose="020B0503020204020204" charset="-122"/>
-                <a:cs typeface="微软雅黑" panose="020B0503020204020204" charset="-122"/>
-              </a:rPr>
-              <a:t/>
             </a:r>
             <a:endParaRPr sz="1300" b="0">
               <a:solidFill>
@@ -11035,28 +10949,6 @@
                 <a:cs typeface="微软雅黑" panose="020B0503020204020204" charset="-122"/>
               </a:rPr>
               <a:t>▪  开源桌宠  Shimeji / Ukagaka（SSP） / VPet / uDesktopMascot</a:t>
-            </a:r>
-            <a:r>
-              <a:rPr sz="1600" b="0">
-                <a:solidFill>
-                  <a:srgbClr val="3B2B26"/>
-                </a:solidFill>
-                <a:latin typeface="微软雅黑" panose="020B0503020204020204" charset="-122"/>
-                <a:ea typeface="微软雅黑" panose="020B0503020204020204" charset="-122"/>
-                <a:cs typeface="微软雅黑" panose="020B0503020204020204" charset="-122"/>
-              </a:rPr>
-              <a:t/>
-            </a:r>
-            <a:r>
-              <a:rPr sz="1300" b="0">
-                <a:solidFill>
-                  <a:srgbClr val="6B5850"/>
-                </a:solidFill>
-                <a:latin typeface="微软雅黑" panose="020B0503020204020204" charset="-122"/>
-                <a:ea typeface="微软雅黑" panose="020B0503020204020204" charset="-122"/>
-                <a:cs typeface="微软雅黑" panose="020B0503020204020204" charset="-122"/>
-              </a:rPr>
-              <a:t/>
             </a:r>
             <a:endParaRPr sz="1300" b="0">
               <a:solidFill>

</xml_diff>